<commit_message>
Update gitbook 2026-10-15 17:35:40
</commit_message>
<xml_diff>
--- a/CommandLinePy/CommandLinePy.pptx
+++ b/CommandLinePy/CommandLinePy.pptx
@@ -203,7 +203,7 @@
           <a:p>
             <a:fld id="{0A4A9009-CAC7-4E8F-B94C-0786B4E8AB52}" type="datetimeFigureOut">
               <a:rPr lang="en-US" smtClean="0"/>
-              <a:t>8/28/2026</a:t>
+              <a:t>10/12/2026</a:t>
             </a:fld>
             <a:endParaRPr lang="en-US"/>
           </a:p>
@@ -1396,7 +1396,7 @@
           <a:p>
             <a:fld id="{9ED8E289-1C12-4E95-8FE8-FF2F994E0C49}" type="datetimeFigureOut">
               <a:rPr lang="en-US" smtClean="0"/>
-              <a:t>8/28/2026</a:t>
+              <a:t>10/12/2026</a:t>
             </a:fld>
             <a:endParaRPr lang="en-US"/>
           </a:p>
@@ -1594,7 +1594,7 @@
           <a:p>
             <a:fld id="{9ED8E289-1C12-4E95-8FE8-FF2F994E0C49}" type="datetimeFigureOut">
               <a:rPr lang="en-US" smtClean="0"/>
-              <a:t>8/28/2026</a:t>
+              <a:t>10/12/2026</a:t>
             </a:fld>
             <a:endParaRPr lang="en-US"/>
           </a:p>
@@ -1802,7 +1802,7 @@
           <a:p>
             <a:fld id="{9ED8E289-1C12-4E95-8FE8-FF2F994E0C49}" type="datetimeFigureOut">
               <a:rPr lang="en-US" smtClean="0"/>
-              <a:t>8/28/2026</a:t>
+              <a:t>10/12/2026</a:t>
             </a:fld>
             <a:endParaRPr lang="en-US"/>
           </a:p>
@@ -2000,7 +2000,7 @@
           <a:p>
             <a:fld id="{9ED8E289-1C12-4E95-8FE8-FF2F994E0C49}" type="datetimeFigureOut">
               <a:rPr lang="en-US" smtClean="0"/>
-              <a:t>8/28/2026</a:t>
+              <a:t>10/12/2026</a:t>
             </a:fld>
             <a:endParaRPr lang="en-US"/>
           </a:p>
@@ -2275,7 +2275,7 @@
           <a:p>
             <a:fld id="{9ED8E289-1C12-4E95-8FE8-FF2F994E0C49}" type="datetimeFigureOut">
               <a:rPr lang="en-US" smtClean="0"/>
-              <a:t>8/28/2026</a:t>
+              <a:t>10/12/2026</a:t>
             </a:fld>
             <a:endParaRPr lang="en-US"/>
           </a:p>
@@ -2540,7 +2540,7 @@
           <a:p>
             <a:fld id="{9ED8E289-1C12-4E95-8FE8-FF2F994E0C49}" type="datetimeFigureOut">
               <a:rPr lang="en-US" smtClean="0"/>
-              <a:t>8/28/2026</a:t>
+              <a:t>10/12/2026</a:t>
             </a:fld>
             <a:endParaRPr lang="en-US"/>
           </a:p>
@@ -2952,7 +2952,7 @@
           <a:p>
             <a:fld id="{9ED8E289-1C12-4E95-8FE8-FF2F994E0C49}" type="datetimeFigureOut">
               <a:rPr lang="en-US" smtClean="0"/>
-              <a:t>8/28/2026</a:t>
+              <a:t>10/12/2026</a:t>
             </a:fld>
             <a:endParaRPr lang="en-US"/>
           </a:p>
@@ -3093,7 +3093,7 @@
           <a:p>
             <a:fld id="{9ED8E289-1C12-4E95-8FE8-FF2F994E0C49}" type="datetimeFigureOut">
               <a:rPr lang="en-US" smtClean="0"/>
-              <a:t>8/28/2026</a:t>
+              <a:t>10/12/2026</a:t>
             </a:fld>
             <a:endParaRPr lang="en-US"/>
           </a:p>
@@ -3206,7 +3206,7 @@
           <a:p>
             <a:fld id="{9ED8E289-1C12-4E95-8FE8-FF2F994E0C49}" type="datetimeFigureOut">
               <a:rPr lang="en-US" smtClean="0"/>
-              <a:t>8/28/2026</a:t>
+              <a:t>10/12/2026</a:t>
             </a:fld>
             <a:endParaRPr lang="en-US"/>
           </a:p>
@@ -3517,7 +3517,7 @@
           <a:p>
             <a:fld id="{9ED8E289-1C12-4E95-8FE8-FF2F994E0C49}" type="datetimeFigureOut">
               <a:rPr lang="en-US" smtClean="0"/>
-              <a:t>8/28/2026</a:t>
+              <a:t>10/12/2026</a:t>
             </a:fld>
             <a:endParaRPr lang="en-US"/>
           </a:p>
@@ -3805,7 +3805,7 @@
           <a:p>
             <a:fld id="{9ED8E289-1C12-4E95-8FE8-FF2F994E0C49}" type="datetimeFigureOut">
               <a:rPr lang="en-US" smtClean="0"/>
-              <a:t>8/28/2026</a:t>
+              <a:t>10/12/2026</a:t>
             </a:fld>
             <a:endParaRPr lang="en-US"/>
           </a:p>
@@ -4046,7 +4046,7 @@
           <a:p>
             <a:fld id="{9ED8E289-1C12-4E95-8FE8-FF2F994E0C49}" type="datetimeFigureOut">
               <a:rPr lang="en-US" smtClean="0"/>
-              <a:t>8/28/2026</a:t>
+              <a:t>10/12/2026</a:t>
             </a:fld>
             <a:endParaRPr lang="en-US"/>
           </a:p>
@@ -4578,7 +4578,7 @@
                   <a:schemeClr val="tx2"/>
                 </a:solidFill>
               </a:rPr>
-              <a:t>Hyland Python Academy @ UCS</a:t>
+              <a:t>Hyland Tech Outreach</a:t>
             </a:r>
           </a:p>
         </p:txBody>

</xml_diff>